<commit_message>
Docs: update AutoJopps etymology wording
Co-Authored-By: Claude Fable 5.1 <noreply@anthropic.com>
Claude-Session: https://claude.ai/code/session_01KP7RHcxHf1s3kBExVDFMc8
</commit_message>
<xml_diff>
--- a/docs/AutoJopps_Investor_Deck_v2.pptx
+++ b/docs/AutoJopps_Investor_Deck_v2.pptx
@@ -2065,7 +2065,7 @@
                 <a:ea typeface="Arial" pitchFamily="34" charset="-122"/>
                 <a:cs typeface="Arial" pitchFamily="34" charset="-120"/>
               </a:rPr>
-              <a:t>AUTOJOPPS  ·  AUTOMATED JOB OPPORTUNITIES AND JOB HOPS</a:t>
+              <a:t>AUTOJOPPS  ·  AUTOMATED NEW JOB OPPORTUNITIES AND SMOOTH JOB-SEARCH OPERATIONS AND JOB HOPS</a:t>
             </a:r>
             <a:endParaRPr lang="en-US" sz="1100" dirty="0"/>
           </a:p>
@@ -2182,7 +2182,7 @@
                 <a:ea typeface="Arial" pitchFamily="34" charset="-122"/>
                 <a:cs typeface="Arial" pitchFamily="34" charset="-120"/>
               </a:rPr>
-              <a:t>AutoJopps (auto-J-opps) = Automated Job Opportunities and Job Hops: receive frequent new job opportunities through automated, fast job applies. Also: AutoJobOpps.</a:t>
+              <a:t>AutoJopps (auto-J-opps) = Automated New Job Opportunities and Smooth Job-Search Operations and Job Hops: receive frequent new job opportunities through automated, fast job applies. Also: AutoJobOpps.</a:t>
             </a:r>
             <a:endParaRPr lang="en-US" sz="1050" dirty="0"/>
           </a:p>
@@ -5802,7 +5802,7 @@
                 <a:ea typeface="Arial" pitchFamily="34" charset="-122"/>
                 <a:cs typeface="Arial" pitchFamily="34" charset="-120"/>
               </a:rPr>
-              <a:t>Automated Job Opportunities and Job Hops. Job applications on autopilot, with you in the loop.</a:t>
+              <a:t>Automated New Job Opportunities and Smooth Job-Search Operations and Job Hops. Job applications on autopilot, with you in the loop.</a:t>
             </a:r>
             <a:endParaRPr lang="en-US" sz="1600" dirty="0"/>
           </a:p>

</xml_diff>